<commit_message>
update stage3 for correct stall diagram
</commit_message>
<xml_diff>
--- a/book/finalproject/RISCVstage3.pptx
+++ b/book/finalproject/RISCVstage3.pptx
@@ -115,7 +115,7 @@
 <file path=ppt/revisionInfo.xml><?xml version="1.0" encoding="utf-8"?>
 <p1510:revInfo xmlns:a="http://schemas.openxmlformats.org/drawingml/2006/main" xmlns:r="http://schemas.openxmlformats.org/officeDocument/2006/relationships" xmlns:p1510="http://schemas.microsoft.com/office/powerpoint/2015/10/main">
   <p1510:revLst>
-    <p1510:client id="{E75867FF-49DB-4DC0-967A-A19776D02C5E}" v="6" dt="2026-03-10T17:14:29.583"/>
+    <p1510:client id="{ACF1FCC7-50D8-4515-B9C3-EEEC3DB5664C}" v="7" dt="2026-04-07T21:43:30.324"/>
   </p1510:revLst>
 </p1510:revInfo>
 </file>
@@ -124,25 +124,17 @@
 <pc:chgInfo xmlns:a="http://schemas.openxmlformats.org/drawingml/2006/main" xmlns:r="http://schemas.openxmlformats.org/officeDocument/2006/relationships" xmlns:ac="http://schemas.microsoft.com/office/drawing/2013/main/command" xmlns:pc="http://schemas.microsoft.com/office/powerpoint/2013/main/command">
   <pc:docChgLst>
     <pc:chgData name="York, George W CIV USAF USAFA DF/DFEC" userId="1fb5875a-4594-4db2-80fb-f0db3de11280" providerId="ADAL" clId="{09330963-85FD-4C99-A81B-94D0EE5CFFEB}"/>
-    <pc:docChg chg="custSel modSld">
-      <pc:chgData name="York, George W CIV USAF USAFA DF/DFEC" userId="1fb5875a-4594-4db2-80fb-f0db3de11280" providerId="ADAL" clId="{09330963-85FD-4C99-A81B-94D0EE5CFFEB}" dt="2026-03-10T17:14:37.305" v="17" actId="1076"/>
+    <pc:docChg chg="undo custSel modSld">
+      <pc:chgData name="York, George W CIV USAF USAFA DF/DFEC" userId="1fb5875a-4594-4db2-80fb-f0db3de11280" providerId="ADAL" clId="{09330963-85FD-4C99-A81B-94D0EE5CFFEB}" dt="2026-04-07T21:43:57.765" v="118" actId="20577"/>
       <pc:docMkLst>
         <pc:docMk/>
       </pc:docMkLst>
       <pc:sldChg chg="addSp delSp modSp mod">
-        <pc:chgData name="York, George W CIV USAF USAFA DF/DFEC" userId="1fb5875a-4594-4db2-80fb-f0db3de11280" providerId="ADAL" clId="{09330963-85FD-4C99-A81B-94D0EE5CFFEB}" dt="2026-03-10T17:14:37.305" v="17" actId="1076"/>
+        <pc:chgData name="York, George W CIV USAF USAFA DF/DFEC" userId="1fb5875a-4594-4db2-80fb-f0db3de11280" providerId="ADAL" clId="{09330963-85FD-4C99-A81B-94D0EE5CFFEB}" dt="2026-04-07T21:43:57.765" v="118" actId="20577"/>
         <pc:sldMkLst>
           <pc:docMk/>
           <pc:sldMk cId="1501170907" sldId="256"/>
         </pc:sldMkLst>
-        <pc:spChg chg="mod">
-          <ac:chgData name="York, George W CIV USAF USAFA DF/DFEC" userId="1fb5875a-4594-4db2-80fb-f0db3de11280" providerId="ADAL" clId="{09330963-85FD-4C99-A81B-94D0EE5CFFEB}" dt="2026-03-05T22:46:17.762" v="4" actId="20577"/>
-          <ac:spMkLst>
-            <pc:docMk/>
-            <pc:sldMk cId="1501170907" sldId="256"/>
-            <ac:spMk id="4" creationId="{FB55267A-D19E-887C-DE49-0FCC56FF700B}"/>
-          </ac:spMkLst>
-        </pc:spChg>
         <pc:spChg chg="add mod">
           <ac:chgData name="York, George W CIV USAF USAFA DF/DFEC" userId="1fb5875a-4594-4db2-80fb-f0db3de11280" providerId="ADAL" clId="{09330963-85FD-4C99-A81B-94D0EE5CFFEB}" dt="2026-03-10T17:10:31.494" v="11" actId="1076"/>
           <ac:spMkLst>
@@ -151,84 +143,116 @@
             <ac:spMk id="17" creationId="{F3C357C1-6CA0-FE49-1679-B84ECC79460C}"/>
           </ac:spMkLst>
         </pc:spChg>
-        <pc:spChg chg="del">
-          <ac:chgData name="York, George W CIV USAF USAFA DF/DFEC" userId="1fb5875a-4594-4db2-80fb-f0db3de11280" providerId="ADAL" clId="{09330963-85FD-4C99-A81B-94D0EE5CFFEB}" dt="2026-03-10T16:47:43.899" v="5" actId="478"/>
+        <pc:spChg chg="mod">
+          <ac:chgData name="York, George W CIV USAF USAFA DF/DFEC" userId="1fb5875a-4594-4db2-80fb-f0db3de11280" providerId="ADAL" clId="{09330963-85FD-4C99-A81B-94D0EE5CFFEB}" dt="2026-04-07T21:17:34.236" v="18" actId="14100"/>
           <ac:spMkLst>
             <pc:docMk/>
             <pc:sldMk cId="1501170907" sldId="256"/>
-            <ac:spMk id="54" creationId="{7C5CCBD1-0844-480F-8141-9A9CAA44FF50}"/>
+            <ac:spMk id="23" creationId="{A8009FE0-7787-A3EB-6282-7D22C75D2C48}"/>
           </ac:spMkLst>
         </pc:spChg>
-        <pc:spChg chg="del">
-          <ac:chgData name="York, George W CIV USAF USAFA DF/DFEC" userId="1fb5875a-4594-4db2-80fb-f0db3de11280" providerId="ADAL" clId="{09330963-85FD-4C99-A81B-94D0EE5CFFEB}" dt="2026-03-10T16:47:43.899" v="5" actId="478"/>
+        <pc:spChg chg="add mod">
+          <ac:chgData name="York, George W CIV USAF USAFA DF/DFEC" userId="1fb5875a-4594-4db2-80fb-f0db3de11280" providerId="ADAL" clId="{09330963-85FD-4C99-A81B-94D0EE5CFFEB}" dt="2026-04-07T21:24:36.037" v="49" actId="1076"/>
           <ac:spMkLst>
             <pc:docMk/>
             <pc:sldMk cId="1501170907" sldId="256"/>
-            <ac:spMk id="57" creationId="{BE8947B1-691B-936E-60AD-9FDFE4A4EA75}"/>
+            <ac:spMk id="59" creationId="{186A631B-F190-7086-D3E4-E64D63EF623D}"/>
           </ac:spMkLst>
         </pc:spChg>
-        <pc:spChg chg="del">
-          <ac:chgData name="York, George W CIV USAF USAFA DF/DFEC" userId="1fb5875a-4594-4db2-80fb-f0db3de11280" providerId="ADAL" clId="{09330963-85FD-4C99-A81B-94D0EE5CFFEB}" dt="2026-03-10T16:47:43.899" v="5" actId="478"/>
+        <pc:spChg chg="add del mod">
+          <ac:chgData name="York, George W CIV USAF USAFA DF/DFEC" userId="1fb5875a-4594-4db2-80fb-f0db3de11280" providerId="ADAL" clId="{09330963-85FD-4C99-A81B-94D0EE5CFFEB}" dt="2026-04-07T21:24:56.863" v="50" actId="478"/>
           <ac:spMkLst>
             <pc:docMk/>
             <pc:sldMk cId="1501170907" sldId="256"/>
-            <ac:spMk id="59" creationId="{62908768-78CB-6AA2-9F8F-560147BBA50C}"/>
+            <ac:spMk id="66" creationId="{D3B8DB5F-1693-7C15-AAE5-35655C0E7637}"/>
           </ac:spMkLst>
         </pc:spChg>
-        <pc:spChg chg="del">
-          <ac:chgData name="York, George W CIV USAF USAFA DF/DFEC" userId="1fb5875a-4594-4db2-80fb-f0db3de11280" providerId="ADAL" clId="{09330963-85FD-4C99-A81B-94D0EE5CFFEB}" dt="2026-03-10T16:47:43.899" v="5" actId="478"/>
+        <pc:spChg chg="add mod">
+          <ac:chgData name="York, George W CIV USAF USAFA DF/DFEC" userId="1fb5875a-4594-4db2-80fb-f0db3de11280" providerId="ADAL" clId="{09330963-85FD-4C99-A81B-94D0EE5CFFEB}" dt="2026-04-07T21:41:27.757" v="59" actId="1076"/>
           <ac:spMkLst>
             <pc:docMk/>
             <pc:sldMk cId="1501170907" sldId="256"/>
-            <ac:spMk id="80" creationId="{55A3E227-0BF3-A73B-3BC7-43B3ED0C951A}"/>
+            <ac:spMk id="67" creationId="{2A1D9753-7066-13C9-A737-FE724AE089F0}"/>
           </ac:spMkLst>
         </pc:spChg>
-        <pc:spChg chg="del">
-          <ac:chgData name="York, George W CIV USAF USAFA DF/DFEC" userId="1fb5875a-4594-4db2-80fb-f0db3de11280" providerId="ADAL" clId="{09330963-85FD-4C99-A81B-94D0EE5CFFEB}" dt="2026-03-10T16:47:43.899" v="5" actId="478"/>
+        <pc:spChg chg="add mod">
+          <ac:chgData name="York, George W CIV USAF USAFA DF/DFEC" userId="1fb5875a-4594-4db2-80fb-f0db3de11280" providerId="ADAL" clId="{09330963-85FD-4C99-A81B-94D0EE5CFFEB}" dt="2026-04-07T21:42:17.969" v="69" actId="1076"/>
           <ac:spMkLst>
             <pc:docMk/>
             <pc:sldMk cId="1501170907" sldId="256"/>
-            <ac:spMk id="84" creationId="{D1142331-E346-04E4-CE7D-40DA0254B7E8}"/>
+            <ac:spMk id="68" creationId="{0182E3FA-2050-1E0B-90D7-8E7982835657}"/>
           </ac:spMkLst>
         </pc:spChg>
-        <pc:spChg chg="add del mod">
-          <ac:chgData name="York, George W CIV USAF USAFA DF/DFEC" userId="1fb5875a-4594-4db2-80fb-f0db3de11280" providerId="ADAL" clId="{09330963-85FD-4C99-A81B-94D0EE5CFFEB}" dt="2026-03-10T16:47:43.899" v="5" actId="478"/>
+        <pc:spChg chg="add mod">
+          <ac:chgData name="York, George W CIV USAF USAFA DF/DFEC" userId="1fb5875a-4594-4db2-80fb-f0db3de11280" providerId="ADAL" clId="{09330963-85FD-4C99-A81B-94D0EE5CFFEB}" dt="2026-04-07T21:42:02.423" v="66" actId="20577"/>
           <ac:spMkLst>
             <pc:docMk/>
             <pc:sldMk cId="1501170907" sldId="256"/>
-            <ac:spMk id="105" creationId="{8150CAF1-DAFF-41B1-37D9-3AA58EDF71DA}"/>
+            <ac:spMk id="84" creationId="{465A98EB-4880-884F-D153-0515CE8BDEB2}"/>
           </ac:spMkLst>
         </pc:spChg>
         <pc:spChg chg="add mod">
-          <ac:chgData name="York, George W CIV USAF USAFA DF/DFEC" userId="1fb5875a-4594-4db2-80fb-f0db3de11280" providerId="ADAL" clId="{09330963-85FD-4C99-A81B-94D0EE5CFFEB}" dt="2026-03-05T22:29:55.846" v="0"/>
+          <ac:chgData name="York, George W CIV USAF USAFA DF/DFEC" userId="1fb5875a-4594-4db2-80fb-f0db3de11280" providerId="ADAL" clId="{09330963-85FD-4C99-A81B-94D0EE5CFFEB}" dt="2026-04-07T21:42:43.586" v="74" actId="20577"/>
+          <ac:spMkLst>
+            <pc:docMk/>
+            <pc:sldMk cId="1501170907" sldId="256"/>
+            <ac:spMk id="86" creationId="{33E037D7-FFD6-1A3F-9638-8C8F09EEE8FF}"/>
+          </ac:spMkLst>
+        </pc:spChg>
+        <pc:spChg chg="add mod">
+          <ac:chgData name="York, George W CIV USAF USAFA DF/DFEC" userId="1fb5875a-4594-4db2-80fb-f0db3de11280" providerId="ADAL" clId="{09330963-85FD-4C99-A81B-94D0EE5CFFEB}" dt="2026-04-07T21:43:20.962" v="87" actId="1076"/>
+          <ac:spMkLst>
+            <pc:docMk/>
+            <pc:sldMk cId="1501170907" sldId="256"/>
+            <ac:spMk id="88" creationId="{3444F36D-44DB-30F1-9A93-0662301A031E}"/>
+          </ac:spMkLst>
+        </pc:spChg>
+        <pc:spChg chg="add mod">
+          <ac:chgData name="York, George W CIV USAF USAFA DF/DFEC" userId="1fb5875a-4594-4db2-80fb-f0db3de11280" providerId="ADAL" clId="{09330963-85FD-4C99-A81B-94D0EE5CFFEB}" dt="2026-04-07T21:43:57.765" v="118" actId="20577"/>
+          <ac:spMkLst>
+            <pc:docMk/>
+            <pc:sldMk cId="1501170907" sldId="256"/>
+            <ac:spMk id="92" creationId="{17776570-4E75-3096-0631-C034786BC80E}"/>
+          </ac:spMkLst>
+        </pc:spChg>
+        <pc:spChg chg="mod">
+          <ac:chgData name="York, George W CIV USAF USAFA DF/DFEC" userId="1fb5875a-4594-4db2-80fb-f0db3de11280" providerId="ADAL" clId="{09330963-85FD-4C99-A81B-94D0EE5CFFEB}" dt="2026-04-07T21:18:37.994" v="24" actId="14100"/>
           <ac:spMkLst>
             <pc:docMk/>
             <pc:sldMk cId="1501170907" sldId="256"/>
             <ac:spMk id="106" creationId="{802EBAD3-1207-E175-F4E6-F1CAAFD5CB84}"/>
           </ac:spMkLst>
         </pc:spChg>
-        <pc:spChg chg="add mod">
-          <ac:chgData name="York, George W CIV USAF USAFA DF/DFEC" userId="1fb5875a-4594-4db2-80fb-f0db3de11280" providerId="ADAL" clId="{09330963-85FD-4C99-A81B-94D0EE5CFFEB}" dt="2026-03-05T22:29:55.846" v="0"/>
+        <pc:spChg chg="mod">
+          <ac:chgData name="York, George W CIV USAF USAFA DF/DFEC" userId="1fb5875a-4594-4db2-80fb-f0db3de11280" providerId="ADAL" clId="{09330963-85FD-4C99-A81B-94D0EE5CFFEB}" dt="2026-04-07T21:18:37.994" v="24" actId="14100"/>
           <ac:spMkLst>
             <pc:docMk/>
             <pc:sldMk cId="1501170907" sldId="256"/>
             <ac:spMk id="107" creationId="{B1546BBC-B812-DED8-4B26-9FABE47BC3AA}"/>
           </ac:spMkLst>
         </pc:spChg>
-        <pc:spChg chg="add mod">
-          <ac:chgData name="York, George W CIV USAF USAFA DF/DFEC" userId="1fb5875a-4594-4db2-80fb-f0db3de11280" providerId="ADAL" clId="{09330963-85FD-4C99-A81B-94D0EE5CFFEB}" dt="2026-03-05T22:29:55.846" v="0"/>
+        <pc:spChg chg="mod">
+          <ac:chgData name="York, George W CIV USAF USAFA DF/DFEC" userId="1fb5875a-4594-4db2-80fb-f0db3de11280" providerId="ADAL" clId="{09330963-85FD-4C99-A81B-94D0EE5CFFEB}" dt="2026-04-07T21:18:37.994" v="24" actId="14100"/>
           <ac:spMkLst>
             <pc:docMk/>
             <pc:sldMk cId="1501170907" sldId="256"/>
             <ac:spMk id="109" creationId="{A81CABDD-6671-8136-C507-5421CBF47C22}"/>
           </ac:spMkLst>
         </pc:spChg>
-        <pc:spChg chg="add mod">
-          <ac:chgData name="York, George W CIV USAF USAFA DF/DFEC" userId="1fb5875a-4594-4db2-80fb-f0db3de11280" providerId="ADAL" clId="{09330963-85FD-4C99-A81B-94D0EE5CFFEB}" dt="2026-03-05T22:29:55.846" v="0"/>
+        <pc:spChg chg="mod">
+          <ac:chgData name="York, George W CIV USAF USAFA DF/DFEC" userId="1fb5875a-4594-4db2-80fb-f0db3de11280" providerId="ADAL" clId="{09330963-85FD-4C99-A81B-94D0EE5CFFEB}" dt="2026-04-07T21:18:37.994" v="24" actId="14100"/>
           <ac:spMkLst>
             <pc:docMk/>
             <pc:sldMk cId="1501170907" sldId="256"/>
             <ac:spMk id="110" creationId="{F182B11B-81F0-C7FD-76B3-7C27A04FAE43}"/>
+          </ac:spMkLst>
+        </pc:spChg>
+        <pc:spChg chg="mod">
+          <ac:chgData name="York, George W CIV USAF USAFA DF/DFEC" userId="1fb5875a-4594-4db2-80fb-f0db3de11280" providerId="ADAL" clId="{09330963-85FD-4C99-A81B-94D0EE5CFFEB}" dt="2026-04-07T21:20:41.767" v="43" actId="1076"/>
+          <ac:spMkLst>
+            <pc:docMk/>
+            <pc:sldMk cId="1501170907" sldId="256"/>
+            <ac:spMk id="127" creationId="{E8F9A210-9B95-3371-FB33-95617722EA31}"/>
           </ac:spMkLst>
         </pc:spChg>
         <pc:spChg chg="add mod">
@@ -295,46 +319,6 @@
             <ac:spMk id="187" creationId="{02F76C24-B5A2-EF6E-0213-72D63A9FAEFB}"/>
           </ac:spMkLst>
         </pc:spChg>
-        <pc:spChg chg="del">
-          <ac:chgData name="York, George W CIV USAF USAFA DF/DFEC" userId="1fb5875a-4594-4db2-80fb-f0db3de11280" providerId="ADAL" clId="{09330963-85FD-4C99-A81B-94D0EE5CFFEB}" dt="2026-03-10T16:47:43.899" v="5" actId="478"/>
-          <ac:spMkLst>
-            <pc:docMk/>
-            <pc:sldMk cId="1501170907" sldId="256"/>
-            <ac:spMk id="264" creationId="{18102C07-F7E1-1AF1-477B-00B68F177F07}"/>
-          </ac:spMkLst>
-        </pc:spChg>
-        <pc:spChg chg="del">
-          <ac:chgData name="York, George W CIV USAF USAFA DF/DFEC" userId="1fb5875a-4594-4db2-80fb-f0db3de11280" providerId="ADAL" clId="{09330963-85FD-4C99-A81B-94D0EE5CFFEB}" dt="2026-03-10T16:47:43.899" v="5" actId="478"/>
-          <ac:spMkLst>
-            <pc:docMk/>
-            <pc:sldMk cId="1501170907" sldId="256"/>
-            <ac:spMk id="265" creationId="{00A05C49-A5A2-CC74-BAEB-00CF47323BC9}"/>
-          </ac:spMkLst>
-        </pc:spChg>
-        <pc:spChg chg="del">
-          <ac:chgData name="York, George W CIV USAF USAFA DF/DFEC" userId="1fb5875a-4594-4db2-80fb-f0db3de11280" providerId="ADAL" clId="{09330963-85FD-4C99-A81B-94D0EE5CFFEB}" dt="2026-03-10T16:47:43.899" v="5" actId="478"/>
-          <ac:spMkLst>
-            <pc:docMk/>
-            <pc:sldMk cId="1501170907" sldId="256"/>
-            <ac:spMk id="266" creationId="{B178740B-BE6B-31B0-B4FD-0ED1D3EABF36}"/>
-          </ac:spMkLst>
-        </pc:spChg>
-        <pc:grpChg chg="del">
-          <ac:chgData name="York, George W CIV USAF USAFA DF/DFEC" userId="1fb5875a-4594-4db2-80fb-f0db3de11280" providerId="ADAL" clId="{09330963-85FD-4C99-A81B-94D0EE5CFFEB}" dt="2026-03-10T17:14:24.856" v="15" actId="478"/>
-          <ac:grpSpMkLst>
-            <pc:docMk/>
-            <pc:sldMk cId="1501170907" sldId="256"/>
-            <ac:grpSpMk id="30" creationId="{F29CD4F1-4D65-2071-CB5D-56C21B0A8ADD}"/>
-          </ac:grpSpMkLst>
-        </pc:grpChg>
-        <pc:grpChg chg="del">
-          <ac:chgData name="York, George W CIV USAF USAFA DF/DFEC" userId="1fb5875a-4594-4db2-80fb-f0db3de11280" providerId="ADAL" clId="{09330963-85FD-4C99-A81B-94D0EE5CFFEB}" dt="2026-03-10T16:47:43.899" v="5" actId="478"/>
-          <ac:grpSpMkLst>
-            <pc:docMk/>
-            <pc:sldMk cId="1501170907" sldId="256"/>
-            <ac:grpSpMk id="61" creationId="{16FC76F5-1B0B-DFD2-2DFE-467D7246D31F}"/>
-          </ac:grpSpMkLst>
-        </pc:grpChg>
         <pc:grpChg chg="add mod">
           <ac:chgData name="York, George W CIV USAF USAFA DF/DFEC" userId="1fb5875a-4594-4db2-80fb-f0db3de11280" providerId="ADAL" clId="{09330963-85FD-4C99-A81B-94D0EE5CFFEB}" dt="2026-03-10T16:47:45.074" v="6"/>
           <ac:grpSpMkLst>
@@ -351,52 +335,12 @@
             <ac:grpSpMk id="144" creationId="{668D9262-FD4F-8437-B65A-FF28CF8998C5}"/>
           </ac:grpSpMkLst>
         </pc:grpChg>
-        <pc:picChg chg="del">
-          <ac:chgData name="York, George W CIV USAF USAFA DF/DFEC" userId="1fb5875a-4594-4db2-80fb-f0db3de11280" providerId="ADAL" clId="{09330963-85FD-4C99-A81B-94D0EE5CFFEB}" dt="2026-03-10T17:14:07.197" v="12" actId="478"/>
-          <ac:picMkLst>
-            <pc:docMk/>
-            <pc:sldMk cId="1501170907" sldId="256"/>
-            <ac:picMk id="36" creationId="{7D1B8B85-7F90-6201-21E9-F6ABDFFBBFF8}"/>
-          </ac:picMkLst>
-        </pc:picChg>
-        <pc:cxnChg chg="del">
-          <ac:chgData name="York, George W CIV USAF USAFA DF/DFEC" userId="1fb5875a-4594-4db2-80fb-f0db3de11280" providerId="ADAL" clId="{09330963-85FD-4C99-A81B-94D0EE5CFFEB}" dt="2026-03-10T16:47:53.742" v="7" actId="478"/>
-          <ac:cxnSpMkLst>
-            <pc:docMk/>
-            <pc:sldMk cId="1501170907" sldId="256"/>
-            <ac:cxnSpMk id="17" creationId="{D24E488E-A173-AFA0-3F6A-78FF8CC6952B}"/>
-          </ac:cxnSpMkLst>
-        </pc:cxnChg>
-        <pc:cxnChg chg="del">
-          <ac:chgData name="York, George W CIV USAF USAFA DF/DFEC" userId="1fb5875a-4594-4db2-80fb-f0db3de11280" providerId="ADAL" clId="{09330963-85FD-4C99-A81B-94D0EE5CFFEB}" dt="2026-03-10T16:47:53.742" v="7" actId="478"/>
-          <ac:cxnSpMkLst>
-            <pc:docMk/>
-            <pc:sldMk cId="1501170907" sldId="256"/>
-            <ac:cxnSpMk id="26" creationId="{EFC7A41C-61ED-49E4-BA0B-27EC82F62902}"/>
-          </ac:cxnSpMkLst>
-        </pc:cxnChg>
         <pc:cxnChg chg="add mod">
           <ac:chgData name="York, George W CIV USAF USAFA DF/DFEC" userId="1fb5875a-4594-4db2-80fb-f0db3de11280" providerId="ADAL" clId="{09330963-85FD-4C99-A81B-94D0EE5CFFEB}" dt="2026-03-10T17:14:37.305" v="17" actId="1076"/>
           <ac:cxnSpMkLst>
             <pc:docMk/>
             <pc:sldMk cId="1501170907" sldId="256"/>
             <ac:cxnSpMk id="26" creationId="{F93FF150-8370-FB86-5E5C-59855FA6B568}"/>
-          </ac:cxnSpMkLst>
-        </pc:cxnChg>
-        <pc:cxnChg chg="del">
-          <ac:chgData name="York, George W CIV USAF USAFA DF/DFEC" userId="1fb5875a-4594-4db2-80fb-f0db3de11280" providerId="ADAL" clId="{09330963-85FD-4C99-A81B-94D0EE5CFFEB}" dt="2026-03-10T16:47:53.742" v="7" actId="478"/>
-          <ac:cxnSpMkLst>
-            <pc:docMk/>
-            <pc:sldMk cId="1501170907" sldId="256"/>
-            <ac:cxnSpMk id="28" creationId="{EE79F449-2B1D-87A9-9E7B-9DD8C11C7B9B}"/>
-          </ac:cxnSpMkLst>
-        </pc:cxnChg>
-        <pc:cxnChg chg="del">
-          <ac:chgData name="York, George W CIV USAF USAFA DF/DFEC" userId="1fb5875a-4594-4db2-80fb-f0db3de11280" providerId="ADAL" clId="{09330963-85FD-4C99-A81B-94D0EE5CFFEB}" dt="2026-03-10T17:14:18.066" v="14" actId="478"/>
-          <ac:cxnSpMkLst>
-            <pc:docMk/>
-            <pc:sldMk cId="1501170907" sldId="256"/>
-            <ac:cxnSpMk id="37" creationId="{A09C37C1-E5D0-9FBA-A932-2F98BACEC0B2}"/>
           </ac:cxnSpMkLst>
         </pc:cxnChg>
         <pc:cxnChg chg="mod">
@@ -408,47 +352,127 @@
           </ac:cxnSpMkLst>
         </pc:cxnChg>
         <pc:cxnChg chg="add mod">
-          <ac:chgData name="York, George W CIV USAF USAFA DF/DFEC" userId="1fb5875a-4594-4db2-80fb-f0db3de11280" providerId="ADAL" clId="{09330963-85FD-4C99-A81B-94D0EE5CFFEB}" dt="2026-03-05T22:29:55.846" v="0"/>
+          <ac:chgData name="York, George W CIV USAF USAFA DF/DFEC" userId="1fb5875a-4594-4db2-80fb-f0db3de11280" providerId="ADAL" clId="{09330963-85FD-4C99-A81B-94D0EE5CFFEB}" dt="2026-04-07T21:20:52.576" v="45" actId="1076"/>
+          <ac:cxnSpMkLst>
+            <pc:docMk/>
+            <pc:sldMk cId="1501170907" sldId="256"/>
+            <ac:cxnSpMk id="58" creationId="{FC5A1AC6-CF53-3493-56F7-589C74FEA80A}"/>
+          </ac:cxnSpMkLst>
+        </pc:cxnChg>
+        <pc:cxnChg chg="add del mod">
+          <ac:chgData name="York, George W CIV USAF USAFA DF/DFEC" userId="1fb5875a-4594-4db2-80fb-f0db3de11280" providerId="ADAL" clId="{09330963-85FD-4C99-A81B-94D0EE5CFFEB}" dt="2026-04-07T21:24:57.993" v="51" actId="478"/>
+          <ac:cxnSpMkLst>
+            <pc:docMk/>
+            <pc:sldMk cId="1501170907" sldId="256"/>
+            <ac:cxnSpMk id="61" creationId="{160F255A-AA1C-9C42-A50B-995EFED2120D}"/>
+          </ac:cxnSpMkLst>
+        </pc:cxnChg>
+        <pc:cxnChg chg="add mod">
+          <ac:chgData name="York, George W CIV USAF USAFA DF/DFEC" userId="1fb5875a-4594-4db2-80fb-f0db3de11280" providerId="ADAL" clId="{09330963-85FD-4C99-A81B-94D0EE5CFFEB}" dt="2026-04-07T21:41:27.757" v="59" actId="1076"/>
+          <ac:cxnSpMkLst>
+            <pc:docMk/>
+            <pc:sldMk cId="1501170907" sldId="256"/>
+            <ac:cxnSpMk id="72" creationId="{4B1579FE-1A01-8122-525C-1BF52DFA00E3}"/>
+          </ac:cxnSpMkLst>
+        </pc:cxnChg>
+        <pc:cxnChg chg="add del mod">
+          <ac:chgData name="York, George W CIV USAF USAFA DF/DFEC" userId="1fb5875a-4594-4db2-80fb-f0db3de11280" providerId="ADAL" clId="{09330963-85FD-4C99-A81B-94D0EE5CFFEB}" dt="2026-04-07T21:42:21.595" v="70" actId="478"/>
+          <ac:cxnSpMkLst>
+            <pc:docMk/>
+            <pc:sldMk cId="1501170907" sldId="256"/>
+            <ac:cxnSpMk id="75" creationId="{F3F07CC7-3576-96D0-5E9D-2FA4D6604664}"/>
+          </ac:cxnSpMkLst>
+        </pc:cxnChg>
+        <pc:cxnChg chg="add del mod">
+          <ac:chgData name="York, George W CIV USAF USAFA DF/DFEC" userId="1fb5875a-4594-4db2-80fb-f0db3de11280" providerId="ADAL" clId="{09330963-85FD-4C99-A81B-94D0EE5CFFEB}" dt="2026-04-07T21:42:23.514" v="71" actId="478"/>
+          <ac:cxnSpMkLst>
+            <pc:docMk/>
+            <pc:sldMk cId="1501170907" sldId="256"/>
+            <ac:cxnSpMk id="76" creationId="{E1F4FD1C-64DA-F8D6-BE06-BB885DCFC055}"/>
+          </ac:cxnSpMkLst>
+        </pc:cxnChg>
+        <pc:cxnChg chg="add mod">
+          <ac:chgData name="York, George W CIV USAF USAFA DF/DFEC" userId="1fb5875a-4594-4db2-80fb-f0db3de11280" providerId="ADAL" clId="{09330963-85FD-4C99-A81B-94D0EE5CFFEB}" dt="2026-04-07T21:41:45.405" v="62" actId="14100"/>
+          <ac:cxnSpMkLst>
+            <pc:docMk/>
+            <pc:sldMk cId="1501170907" sldId="256"/>
+            <ac:cxnSpMk id="77" creationId="{947FAF0E-6260-E911-7037-28D14C3C707B}"/>
+          </ac:cxnSpMkLst>
+        </pc:cxnChg>
+        <pc:cxnChg chg="mod">
+          <ac:chgData name="York, George W CIV USAF USAFA DF/DFEC" userId="1fb5875a-4594-4db2-80fb-f0db3de11280" providerId="ADAL" clId="{09330963-85FD-4C99-A81B-94D0EE5CFFEB}" dt="2026-04-07T21:18:37.994" v="24" actId="14100"/>
           <ac:cxnSpMkLst>
             <pc:docMk/>
             <pc:sldMk cId="1501170907" sldId="256"/>
             <ac:cxnSpMk id="108" creationId="{55D04E53-F0F2-CC32-832F-AD990A0BD8D2}"/>
           </ac:cxnSpMkLst>
         </pc:cxnChg>
+        <pc:cxnChg chg="mod">
+          <ac:chgData name="York, George W CIV USAF USAFA DF/DFEC" userId="1fb5875a-4594-4db2-80fb-f0db3de11280" providerId="ADAL" clId="{09330963-85FD-4C99-A81B-94D0EE5CFFEB}" dt="2026-04-07T21:20:27.308" v="41" actId="208"/>
+          <ac:cxnSpMkLst>
+            <pc:docMk/>
+            <pc:sldMk cId="1501170907" sldId="256"/>
+            <ac:cxnSpMk id="118" creationId="{3FFE2C33-996E-7ADF-F9EF-9E2CF7B04F43}"/>
+          </ac:cxnSpMkLst>
+        </pc:cxnChg>
+        <pc:cxnChg chg="mod">
+          <ac:chgData name="York, George W CIV USAF USAFA DF/DFEC" userId="1fb5875a-4594-4db2-80fb-f0db3de11280" providerId="ADAL" clId="{09330963-85FD-4C99-A81B-94D0EE5CFFEB}" dt="2026-04-07T21:41:31.559" v="60" actId="1076"/>
+          <ac:cxnSpMkLst>
+            <pc:docMk/>
+            <pc:sldMk cId="1501170907" sldId="256"/>
+            <ac:cxnSpMk id="119" creationId="{E7E3730A-42E6-0433-39FD-2ACC0255676D}"/>
+          </ac:cxnSpMkLst>
+        </pc:cxnChg>
         <pc:cxnChg chg="add mod">
-          <ac:chgData name="York, George W CIV USAF USAFA DF/DFEC" userId="1fb5875a-4594-4db2-80fb-f0db3de11280" providerId="ADAL" clId="{09330963-85FD-4C99-A81B-94D0EE5CFFEB}" dt="2026-03-05T22:29:55.846" v="0"/>
+          <ac:chgData name="York, George W CIV USAF USAFA DF/DFEC" userId="1fb5875a-4594-4db2-80fb-f0db3de11280" providerId="ADAL" clId="{09330963-85FD-4C99-A81B-94D0EE5CFFEB}" dt="2026-04-07T21:20:21.699" v="40" actId="208"/>
           <ac:cxnSpMkLst>
             <pc:docMk/>
             <pc:sldMk cId="1501170907" sldId="256"/>
             <ac:cxnSpMk id="120" creationId="{1883FA79-CBE1-81F9-475F-742DC442633A}"/>
           </ac:cxnSpMkLst>
         </pc:cxnChg>
-        <pc:cxnChg chg="add mod">
-          <ac:chgData name="York, George W CIV USAF USAFA DF/DFEC" userId="1fb5875a-4594-4db2-80fb-f0db3de11280" providerId="ADAL" clId="{09330963-85FD-4C99-A81B-94D0EE5CFFEB}" dt="2026-03-05T22:29:55.846" v="0"/>
+        <pc:cxnChg chg="mod">
+          <ac:chgData name="York, George W CIV USAF USAFA DF/DFEC" userId="1fb5875a-4594-4db2-80fb-f0db3de11280" providerId="ADAL" clId="{09330963-85FD-4C99-A81B-94D0EE5CFFEB}" dt="2026-04-07T21:20:09.242" v="38" actId="208"/>
           <ac:cxnSpMkLst>
             <pc:docMk/>
             <pc:sldMk cId="1501170907" sldId="256"/>
             <ac:cxnSpMk id="121" creationId="{D53ADBF7-10DC-5789-46E9-813992762F1C}"/>
           </ac:cxnSpMkLst>
         </pc:cxnChg>
-        <pc:cxnChg chg="add mod">
-          <ac:chgData name="York, George W CIV USAF USAFA DF/DFEC" userId="1fb5875a-4594-4db2-80fb-f0db3de11280" providerId="ADAL" clId="{09330963-85FD-4C99-A81B-94D0EE5CFFEB}" dt="2026-03-05T22:29:55.846" v="0"/>
+        <pc:cxnChg chg="mod">
+          <ac:chgData name="York, George W CIV USAF USAFA DF/DFEC" userId="1fb5875a-4594-4db2-80fb-f0db3de11280" providerId="ADAL" clId="{09330963-85FD-4C99-A81B-94D0EE5CFFEB}" dt="2026-04-07T21:20:15.198" v="39" actId="208"/>
+          <ac:cxnSpMkLst>
+            <pc:docMk/>
+            <pc:sldMk cId="1501170907" sldId="256"/>
+            <ac:cxnSpMk id="122" creationId="{47FF72DD-5839-7297-77B0-F5EC466118C5}"/>
+          </ac:cxnSpMkLst>
+        </pc:cxnChg>
+        <pc:cxnChg chg="mod">
+          <ac:chgData name="York, George W CIV USAF USAFA DF/DFEC" userId="1fb5875a-4594-4db2-80fb-f0db3de11280" providerId="ADAL" clId="{09330963-85FD-4C99-A81B-94D0EE5CFFEB}" dt="2026-04-07T21:20:03.539" v="37" actId="208"/>
           <ac:cxnSpMkLst>
             <pc:docMk/>
             <pc:sldMk cId="1501170907" sldId="256"/>
             <ac:cxnSpMk id="123" creationId="{61CB085F-EFA5-81F0-171A-B0F01423DFC7}"/>
           </ac:cxnSpMkLst>
         </pc:cxnChg>
-        <pc:cxnChg chg="add mod">
-          <ac:chgData name="York, George W CIV USAF USAFA DF/DFEC" userId="1fb5875a-4594-4db2-80fb-f0db3de11280" providerId="ADAL" clId="{09330963-85FD-4C99-A81B-94D0EE5CFFEB}" dt="2026-03-05T22:29:55.846" v="0"/>
+        <pc:cxnChg chg="mod">
+          <ac:chgData name="York, George W CIV USAF USAFA DF/DFEC" userId="1fb5875a-4594-4db2-80fb-f0db3de11280" providerId="ADAL" clId="{09330963-85FD-4C99-A81B-94D0EE5CFFEB}" dt="2026-04-07T21:19:57.574" v="36" actId="208"/>
+          <ac:cxnSpMkLst>
+            <pc:docMk/>
+            <pc:sldMk cId="1501170907" sldId="256"/>
+            <ac:cxnSpMk id="124" creationId="{A7AA200C-FCA9-EE26-397A-A699E5A6646F}"/>
+          </ac:cxnSpMkLst>
+        </pc:cxnChg>
+        <pc:cxnChg chg="mod">
+          <ac:chgData name="York, George W CIV USAF USAFA DF/DFEC" userId="1fb5875a-4594-4db2-80fb-f0db3de11280" providerId="ADAL" clId="{09330963-85FD-4C99-A81B-94D0EE5CFFEB}" dt="2026-04-07T21:18:37.994" v="24" actId="14100"/>
           <ac:cxnSpMkLst>
             <pc:docMk/>
             <pc:sldMk cId="1501170907" sldId="256"/>
             <ac:cxnSpMk id="125" creationId="{EC42D385-1455-5F7D-5DE9-63C32D5B7E54}"/>
           </ac:cxnSpMkLst>
         </pc:cxnChg>
-        <pc:cxnChg chg="add mod">
-          <ac:chgData name="York, George W CIV USAF USAFA DF/DFEC" userId="1fb5875a-4594-4db2-80fb-f0db3de11280" providerId="ADAL" clId="{09330963-85FD-4C99-A81B-94D0EE5CFFEB}" dt="2026-03-05T22:29:55.846" v="0"/>
+        <pc:cxnChg chg="mod">
+          <ac:chgData name="York, George W CIV USAF USAFA DF/DFEC" userId="1fb5875a-4594-4db2-80fb-f0db3de11280" providerId="ADAL" clId="{09330963-85FD-4C99-A81B-94D0EE5CFFEB}" dt="2026-04-07T21:41:35.047" v="61" actId="14100"/>
           <ac:cxnSpMkLst>
             <pc:docMk/>
             <pc:sldMk cId="1501170907" sldId="256"/>
@@ -624,7 +648,7 @@
           <a:p>
             <a:fld id="{51AFF834-1BEC-4F95-9622-28B5DCC1FE16}" type="datetimeFigureOut">
               <a:rPr lang="en-US" smtClean="0"/>
-              <a:t>3/10/2026</a:t>
+              <a:t>4/7/2026</a:t>
             </a:fld>
             <a:endParaRPr lang="en-US"/>
           </a:p>
@@ -822,7 +846,7 @@
           <a:p>
             <a:fld id="{51AFF834-1BEC-4F95-9622-28B5DCC1FE16}" type="datetimeFigureOut">
               <a:rPr lang="en-US" smtClean="0"/>
-              <a:t>3/10/2026</a:t>
+              <a:t>4/7/2026</a:t>
             </a:fld>
             <a:endParaRPr lang="en-US"/>
           </a:p>
@@ -1030,7 +1054,7 @@
           <a:p>
             <a:fld id="{51AFF834-1BEC-4F95-9622-28B5DCC1FE16}" type="datetimeFigureOut">
               <a:rPr lang="en-US" smtClean="0"/>
-              <a:t>3/10/2026</a:t>
+              <a:t>4/7/2026</a:t>
             </a:fld>
             <a:endParaRPr lang="en-US"/>
           </a:p>
@@ -1228,7 +1252,7 @@
           <a:p>
             <a:fld id="{51AFF834-1BEC-4F95-9622-28B5DCC1FE16}" type="datetimeFigureOut">
               <a:rPr lang="en-US" smtClean="0"/>
-              <a:t>3/10/2026</a:t>
+              <a:t>4/7/2026</a:t>
             </a:fld>
             <a:endParaRPr lang="en-US"/>
           </a:p>
@@ -1503,7 +1527,7 @@
           <a:p>
             <a:fld id="{51AFF834-1BEC-4F95-9622-28B5DCC1FE16}" type="datetimeFigureOut">
               <a:rPr lang="en-US" smtClean="0"/>
-              <a:t>3/10/2026</a:t>
+              <a:t>4/7/2026</a:t>
             </a:fld>
             <a:endParaRPr lang="en-US"/>
           </a:p>
@@ -1768,7 +1792,7 @@
           <a:p>
             <a:fld id="{51AFF834-1BEC-4F95-9622-28B5DCC1FE16}" type="datetimeFigureOut">
               <a:rPr lang="en-US" smtClean="0"/>
-              <a:t>3/10/2026</a:t>
+              <a:t>4/7/2026</a:t>
             </a:fld>
             <a:endParaRPr lang="en-US"/>
           </a:p>
@@ -2180,7 +2204,7 @@
           <a:p>
             <a:fld id="{51AFF834-1BEC-4F95-9622-28B5DCC1FE16}" type="datetimeFigureOut">
               <a:rPr lang="en-US" smtClean="0"/>
-              <a:t>3/10/2026</a:t>
+              <a:t>4/7/2026</a:t>
             </a:fld>
             <a:endParaRPr lang="en-US"/>
           </a:p>
@@ -2321,7 +2345,7 @@
           <a:p>
             <a:fld id="{51AFF834-1BEC-4F95-9622-28B5DCC1FE16}" type="datetimeFigureOut">
               <a:rPr lang="en-US" smtClean="0"/>
-              <a:t>3/10/2026</a:t>
+              <a:t>4/7/2026</a:t>
             </a:fld>
             <a:endParaRPr lang="en-US"/>
           </a:p>
@@ -2434,7 +2458,7 @@
           <a:p>
             <a:fld id="{51AFF834-1BEC-4F95-9622-28B5DCC1FE16}" type="datetimeFigureOut">
               <a:rPr lang="en-US" smtClean="0"/>
-              <a:t>3/10/2026</a:t>
+              <a:t>4/7/2026</a:t>
             </a:fld>
             <a:endParaRPr lang="en-US"/>
           </a:p>
@@ -2745,7 +2769,7 @@
           <a:p>
             <a:fld id="{51AFF834-1BEC-4F95-9622-28B5DCC1FE16}" type="datetimeFigureOut">
               <a:rPr lang="en-US" smtClean="0"/>
-              <a:t>3/10/2026</a:t>
+              <a:t>4/7/2026</a:t>
             </a:fld>
             <a:endParaRPr lang="en-US"/>
           </a:p>
@@ -3033,7 +3057,7 @@
           <a:p>
             <a:fld id="{51AFF834-1BEC-4F95-9622-28B5DCC1FE16}" type="datetimeFigureOut">
               <a:rPr lang="en-US" smtClean="0"/>
-              <a:t>3/10/2026</a:t>
+              <a:t>4/7/2026</a:t>
             </a:fld>
             <a:endParaRPr lang="en-US"/>
           </a:p>
@@ -3274,7 +3298,7 @@
           <a:p>
             <a:fld id="{51AFF834-1BEC-4F95-9622-28B5DCC1FE16}" type="datetimeFigureOut">
               <a:rPr lang="en-US" smtClean="0"/>
-              <a:t>3/10/2026</a:t>
+              <a:t>4/7/2026</a:t>
             </a:fld>
             <a:endParaRPr lang="en-US"/>
           </a:p>
@@ -9118,8 +9142,8 @@
         </p:nvSpPr>
         <p:spPr>
           <a:xfrm>
-            <a:off x="2458496" y="983375"/>
-            <a:ext cx="124516" cy="4611756"/>
+            <a:off x="2458495" y="983375"/>
+            <a:ext cx="125873" cy="3438801"/>
           </a:xfrm>
           <a:prstGeom prst="rect">
             <a:avLst/>
@@ -9219,7 +9243,7 @@
         </p:nvSpPr>
         <p:spPr>
           <a:xfrm>
-            <a:off x="4112869" y="5087156"/>
+            <a:off x="4081802" y="4715527"/>
             <a:ext cx="663423" cy="460640"/>
           </a:xfrm>
           <a:prstGeom prst="rect">
@@ -9271,7 +9295,7 @@
         </p:nvSpPr>
         <p:spPr>
           <a:xfrm>
-            <a:off x="4171777" y="5125610"/>
+            <a:off x="4140710" y="4753981"/>
             <a:ext cx="574196" cy="384721"/>
           </a:xfrm>
           <a:prstGeom prst="rect">
@@ -9280,7 +9304,7 @@
           <a:noFill/>
         </p:spPr>
         <p:txBody>
-          <a:bodyPr wrap="none" rtlCol="0">
+          <a:bodyPr wrap="square" rtlCol="0">
             <a:spAutoFit/>
           </a:bodyPr>
           <a:lstStyle/>
@@ -9316,7 +9340,7 @@
         </p:nvCxnSpPr>
         <p:spPr>
           <a:xfrm>
-            <a:off x="3882996" y="5224369"/>
+            <a:off x="3851929" y="4852740"/>
             <a:ext cx="229874" cy="0"/>
           </a:xfrm>
           <a:prstGeom prst="straightConnector1">
@@ -9358,7 +9382,7 @@
         </p:nvSpPr>
         <p:spPr>
           <a:xfrm>
-            <a:off x="3204207" y="5087370"/>
+            <a:off x="3173140" y="4715741"/>
             <a:ext cx="678789" cy="484706"/>
           </a:xfrm>
           <a:prstGeom prst="rect">
@@ -9410,7 +9434,7 @@
         </p:nvSpPr>
         <p:spPr>
           <a:xfrm>
-            <a:off x="3169553" y="5107257"/>
+            <a:off x="3138486" y="4735628"/>
             <a:ext cx="729687" cy="400110"/>
           </a:xfrm>
           <a:prstGeom prst="rect">
@@ -9419,7 +9443,7 @@
           <a:noFill/>
         </p:spPr>
         <p:txBody>
-          <a:bodyPr wrap="none" rtlCol="0">
+          <a:bodyPr wrap="square" rtlCol="0">
             <a:spAutoFit/>
           </a:bodyPr>
           <a:lstStyle/>
@@ -9455,13 +9479,16 @@
         </p:nvCxnSpPr>
         <p:spPr>
           <a:xfrm>
-            <a:off x="2743887" y="5277871"/>
+            <a:off x="2731530" y="5071925"/>
             <a:ext cx="442253" cy="0"/>
           </a:xfrm>
           <a:prstGeom prst="straightConnector1">
             <a:avLst/>
           </a:prstGeom>
           <a:ln>
+            <a:solidFill>
+              <a:srgbClr val="FF0000"/>
+            </a:solidFill>
             <a:tailEnd type="triangle"/>
           </a:ln>
         </p:spPr>
@@ -9496,7 +9523,7 @@
         </p:nvCxnSpPr>
         <p:spPr>
           <a:xfrm flipH="1">
-            <a:off x="3888841" y="5478179"/>
+            <a:off x="3862656" y="5059827"/>
             <a:ext cx="205614" cy="0"/>
           </a:xfrm>
           <a:prstGeom prst="straightConnector1">
@@ -9540,12 +9567,17 @@
         </p:nvCxnSpPr>
         <p:spPr>
           <a:xfrm>
-            <a:off x="2763237" y="4519030"/>
-            <a:ext cx="0" cy="761538"/>
+            <a:off x="2742642" y="4702781"/>
+            <a:ext cx="0" cy="367608"/>
           </a:xfrm>
           <a:prstGeom prst="line">
             <a:avLst/>
           </a:prstGeom>
+          <a:ln>
+            <a:solidFill>
+              <a:srgbClr val="FF0000"/>
+            </a:solidFill>
+          </a:ln>
         </p:spPr>
         <p:style>
           <a:lnRef idx="2">
@@ -9578,13 +9610,16 @@
         </p:nvCxnSpPr>
         <p:spPr>
           <a:xfrm>
-            <a:off x="2981569" y="5160759"/>
+            <a:off x="2967078" y="4855032"/>
             <a:ext cx="211703" cy="0"/>
           </a:xfrm>
           <a:prstGeom prst="straightConnector1">
             <a:avLst/>
           </a:prstGeom>
           <a:ln>
+            <a:solidFill>
+              <a:srgbClr val="FF0000"/>
+            </a:solidFill>
             <a:tailEnd type="triangle"/>
           </a:ln>
         </p:spPr>
@@ -9612,17 +9647,24 @@
               </a:ext>
             </a:extLst>
           </p:cNvPr>
-          <p:cNvCxnSpPr/>
+          <p:cNvCxnSpPr>
+            <a:cxnSpLocks/>
+          </p:cNvCxnSpPr>
           <p:nvPr/>
         </p:nvCxnSpPr>
         <p:spPr>
-          <a:xfrm flipH="1" flipV="1">
-            <a:off x="2602523" y="4499564"/>
-            <a:ext cx="164123" cy="7703"/>
+          <a:xfrm flipH="1">
+            <a:off x="2332953" y="4719577"/>
+            <a:ext cx="398618" cy="0"/>
           </a:xfrm>
           <a:prstGeom prst="line">
             <a:avLst/>
           </a:prstGeom>
+          <a:ln>
+            <a:solidFill>
+              <a:srgbClr val="FF0000"/>
+            </a:solidFill>
+          </a:ln>
         </p:spPr>
         <p:style>
           <a:lnRef idx="2">
@@ -9648,17 +9690,24 @@
               </a:ext>
             </a:extLst>
           </p:cNvPr>
-          <p:cNvCxnSpPr/>
+          <p:cNvCxnSpPr>
+            <a:cxnSpLocks/>
+          </p:cNvCxnSpPr>
           <p:nvPr/>
         </p:nvCxnSpPr>
         <p:spPr>
           <a:xfrm>
-            <a:off x="2989385" y="4912022"/>
-            <a:ext cx="0" cy="253947"/>
+            <a:off x="2958318" y="4393497"/>
+            <a:ext cx="0" cy="470946"/>
           </a:xfrm>
           <a:prstGeom prst="line">
             <a:avLst/>
           </a:prstGeom>
+          <a:ln>
+            <a:solidFill>
+              <a:srgbClr val="FF0000"/>
+            </a:solidFill>
+          </a:ln>
         </p:spPr>
         <p:style>
           <a:lnRef idx="2">
@@ -9684,17 +9733,24 @@
               </a:ext>
             </a:extLst>
           </p:cNvPr>
-          <p:cNvCxnSpPr/>
+          <p:cNvCxnSpPr>
+            <a:cxnSpLocks/>
+          </p:cNvCxnSpPr>
           <p:nvPr/>
         </p:nvCxnSpPr>
         <p:spPr>
           <a:xfrm>
-            <a:off x="2985477" y="4912022"/>
-            <a:ext cx="2313354" cy="0"/>
+            <a:off x="2581684" y="4384148"/>
+            <a:ext cx="383938" cy="0"/>
           </a:xfrm>
           <a:prstGeom prst="line">
             <a:avLst/>
           </a:prstGeom>
+          <a:ln>
+            <a:solidFill>
+              <a:srgbClr val="FF0000"/>
+            </a:solidFill>
+          </a:ln>
         </p:spPr>
         <p:style>
           <a:lnRef idx="2">
@@ -9720,12 +9776,14 @@
               </a:ext>
             </a:extLst>
           </p:cNvPr>
-          <p:cNvCxnSpPr/>
+          <p:cNvCxnSpPr>
+            <a:cxnSpLocks/>
+          </p:cNvCxnSpPr>
           <p:nvPr/>
         </p:nvCxnSpPr>
         <p:spPr>
           <a:xfrm flipV="1">
-            <a:off x="3977662" y="4996009"/>
+            <a:off x="3946595" y="4624380"/>
             <a:ext cx="0" cy="225402"/>
           </a:xfrm>
           <a:prstGeom prst="straightConnector1">
@@ -9762,13 +9820,15 @@
               </a:ext>
             </a:extLst>
           </p:cNvPr>
-          <p:cNvCxnSpPr/>
+          <p:cNvCxnSpPr>
+            <a:cxnSpLocks/>
+          </p:cNvCxnSpPr>
           <p:nvPr/>
         </p:nvCxnSpPr>
         <p:spPr>
           <a:xfrm>
-            <a:off x="4019628" y="5487290"/>
-            <a:ext cx="0" cy="200651"/>
+            <a:off x="3994657" y="5074508"/>
+            <a:ext cx="0" cy="402752"/>
           </a:xfrm>
           <a:prstGeom prst="straightConnector1">
             <a:avLst/>
@@ -11292,6 +11352,401 @@
           </a:fontRef>
         </p:style>
       </p:cxnSp>
+      <p:cxnSp>
+        <p:nvCxnSpPr>
+          <p:cNvPr id="58" name="Straight Connector 57">
+            <a:extLst>
+              <a:ext uri="{FF2B5EF4-FFF2-40B4-BE49-F238E27FC236}">
+                <a16:creationId xmlns:a16="http://schemas.microsoft.com/office/drawing/2014/main" id="{FC5A1AC6-CF53-3493-56F7-589C74FEA80A}"/>
+              </a:ext>
+            </a:extLst>
+          </p:cNvPr>
+          <p:cNvCxnSpPr/>
+          <p:nvPr/>
+        </p:nvCxnSpPr>
+        <p:spPr>
+          <a:xfrm flipH="1">
+            <a:off x="2774640" y="4319783"/>
+            <a:ext cx="77899" cy="129540"/>
+          </a:xfrm>
+          <a:prstGeom prst="line">
+            <a:avLst/>
+          </a:prstGeom>
+        </p:spPr>
+        <p:style>
+          <a:lnRef idx="2">
+            <a:schemeClr val="accent1"/>
+          </a:lnRef>
+          <a:fillRef idx="0">
+            <a:schemeClr val="accent1"/>
+          </a:fillRef>
+          <a:effectRef idx="1">
+            <a:schemeClr val="accent1"/>
+          </a:effectRef>
+          <a:fontRef idx="minor">
+            <a:schemeClr val="tx1"/>
+          </a:fontRef>
+        </p:style>
+      </p:cxnSp>
+      <p:sp>
+        <p:nvSpPr>
+          <p:cNvPr id="59" name="TextBox 58">
+            <a:extLst>
+              <a:ext uri="{FF2B5EF4-FFF2-40B4-BE49-F238E27FC236}">
+                <a16:creationId xmlns:a16="http://schemas.microsoft.com/office/drawing/2014/main" id="{186A631B-F190-7086-D3E4-E64D63EF623D}"/>
+              </a:ext>
+            </a:extLst>
+          </p:cNvPr>
+          <p:cNvSpPr txBox="1"/>
+          <p:nvPr/>
+        </p:nvSpPr>
+        <p:spPr>
+          <a:xfrm>
+            <a:off x="2656442" y="4215214"/>
+            <a:ext cx="245580" cy="230832"/>
+          </a:xfrm>
+          <a:prstGeom prst="rect">
+            <a:avLst/>
+          </a:prstGeom>
+          <a:noFill/>
+        </p:spPr>
+        <p:txBody>
+          <a:bodyPr wrap="none" rtlCol="0">
+            <a:spAutoFit/>
+          </a:bodyPr>
+          <a:lstStyle/>
+          <a:p>
+            <a:pPr algn="ctr"/>
+            <a:r>
+              <a:rPr lang="en-US" sz="900" dirty="0"/>
+              <a:t>4</a:t>
+            </a:r>
+          </a:p>
+        </p:txBody>
+      </p:sp>
+      <p:sp>
+        <p:nvSpPr>
+          <p:cNvPr id="67" name="Rectangle 66">
+            <a:extLst>
+              <a:ext uri="{FF2B5EF4-FFF2-40B4-BE49-F238E27FC236}">
+                <a16:creationId xmlns:a16="http://schemas.microsoft.com/office/drawing/2014/main" id="{2A1D9753-7066-13C9-A737-FE724AE089F0}"/>
+              </a:ext>
+            </a:extLst>
+          </p:cNvPr>
+          <p:cNvSpPr/>
+          <p:nvPr/>
+        </p:nvSpPr>
+        <p:spPr>
+          <a:xfrm>
+            <a:off x="3849692" y="5487290"/>
+            <a:ext cx="663423" cy="460640"/>
+          </a:xfrm>
+          <a:prstGeom prst="rect">
+            <a:avLst/>
+          </a:prstGeom>
+          <a:solidFill>
+            <a:schemeClr val="bg1"/>
+          </a:solidFill>
+        </p:spPr>
+        <p:style>
+          <a:lnRef idx="2">
+            <a:schemeClr val="accent1">
+              <a:shade val="15000"/>
+            </a:schemeClr>
+          </a:lnRef>
+          <a:fillRef idx="1">
+            <a:schemeClr val="accent1"/>
+          </a:fillRef>
+          <a:effectRef idx="0">
+            <a:schemeClr val="accent1"/>
+          </a:effectRef>
+          <a:fontRef idx="minor">
+            <a:schemeClr val="lt1"/>
+          </a:fontRef>
+        </p:style>
+        <p:txBody>
+          <a:bodyPr rtlCol="0" anchor="ctr"/>
+          <a:lstStyle/>
+          <a:p>
+            <a:pPr algn="ctr"/>
+            <a:r>
+              <a:rPr lang="en-US" dirty="0"/>
+              <a:t>PC</a:t>
+            </a:r>
+          </a:p>
+        </p:txBody>
+      </p:sp>
+      <p:sp>
+        <p:nvSpPr>
+          <p:cNvPr id="68" name="TextBox 67">
+            <a:extLst>
+              <a:ext uri="{FF2B5EF4-FFF2-40B4-BE49-F238E27FC236}">
+                <a16:creationId xmlns:a16="http://schemas.microsoft.com/office/drawing/2014/main" id="{0182E3FA-2050-1E0B-90D7-8E7982835657}"/>
+              </a:ext>
+            </a:extLst>
+          </p:cNvPr>
+          <p:cNvSpPr txBox="1"/>
+          <p:nvPr/>
+        </p:nvSpPr>
+        <p:spPr>
+          <a:xfrm>
+            <a:off x="4327311" y="5584796"/>
+            <a:ext cx="194710" cy="246221"/>
+          </a:xfrm>
+          <a:prstGeom prst="rect">
+            <a:avLst/>
+          </a:prstGeom>
+          <a:noFill/>
+        </p:spPr>
+        <p:txBody>
+          <a:bodyPr wrap="square" rtlCol="0">
+            <a:spAutoFit/>
+          </a:bodyPr>
+          <a:lstStyle/>
+          <a:p>
+            <a:pPr algn="ctr"/>
+            <a:r>
+              <a:rPr lang="en-US" sz="1000" dirty="0"/>
+              <a:t>&gt;</a:t>
+            </a:r>
+            <a:endParaRPr lang="en-US" sz="900" dirty="0"/>
+          </a:p>
+        </p:txBody>
+      </p:sp>
+      <p:cxnSp>
+        <p:nvCxnSpPr>
+          <p:cNvPr id="72" name="Straight Arrow Connector 71">
+            <a:extLst>
+              <a:ext uri="{FF2B5EF4-FFF2-40B4-BE49-F238E27FC236}">
+                <a16:creationId xmlns:a16="http://schemas.microsoft.com/office/drawing/2014/main" id="{4B1579FE-1A01-8122-525C-1BF52DFA00E3}"/>
+              </a:ext>
+            </a:extLst>
+          </p:cNvPr>
+          <p:cNvCxnSpPr>
+            <a:cxnSpLocks/>
+          </p:cNvCxnSpPr>
+          <p:nvPr/>
+        </p:nvCxnSpPr>
+        <p:spPr>
+          <a:xfrm>
+            <a:off x="4518382" y="5717610"/>
+            <a:ext cx="229874" cy="0"/>
+          </a:xfrm>
+          <a:prstGeom prst="straightConnector1">
+            <a:avLst/>
+          </a:prstGeom>
+          <a:ln>
+            <a:solidFill>
+              <a:srgbClr val="FF0000"/>
+            </a:solidFill>
+            <a:tailEnd type="triangle"/>
+          </a:ln>
+        </p:spPr>
+        <p:style>
+          <a:lnRef idx="2">
+            <a:schemeClr val="accent1"/>
+          </a:lnRef>
+          <a:fillRef idx="0">
+            <a:schemeClr val="accent1"/>
+          </a:fillRef>
+          <a:effectRef idx="1">
+            <a:schemeClr val="accent1"/>
+          </a:effectRef>
+          <a:fontRef idx="minor">
+            <a:schemeClr val="tx1"/>
+          </a:fontRef>
+        </p:style>
+      </p:cxnSp>
+      <p:cxnSp>
+        <p:nvCxnSpPr>
+          <p:cNvPr id="77" name="Straight Arrow Connector 76">
+            <a:extLst>
+              <a:ext uri="{FF2B5EF4-FFF2-40B4-BE49-F238E27FC236}">
+                <a16:creationId xmlns:a16="http://schemas.microsoft.com/office/drawing/2014/main" id="{947FAF0E-6260-E911-7037-28D14C3C707B}"/>
+              </a:ext>
+            </a:extLst>
+          </p:cNvPr>
+          <p:cNvCxnSpPr>
+            <a:cxnSpLocks/>
+          </p:cNvCxnSpPr>
+          <p:nvPr/>
+        </p:nvCxnSpPr>
+        <p:spPr>
+          <a:xfrm>
+            <a:off x="4388470" y="5377092"/>
+            <a:ext cx="0" cy="100168"/>
+          </a:xfrm>
+          <a:prstGeom prst="straightConnector1">
+            <a:avLst/>
+          </a:prstGeom>
+          <a:ln>
+            <a:solidFill>
+              <a:srgbClr val="FF0000"/>
+            </a:solidFill>
+            <a:tailEnd type="triangle"/>
+          </a:ln>
+        </p:spPr>
+        <p:style>
+          <a:lnRef idx="2">
+            <a:schemeClr val="accent1"/>
+          </a:lnRef>
+          <a:fillRef idx="0">
+            <a:schemeClr val="accent1"/>
+          </a:fillRef>
+          <a:effectRef idx="1">
+            <a:schemeClr val="accent1"/>
+          </a:effectRef>
+          <a:fontRef idx="minor">
+            <a:schemeClr val="tx1"/>
+          </a:fontRef>
+        </p:style>
+      </p:cxnSp>
+      <p:sp>
+        <p:nvSpPr>
+          <p:cNvPr id="84" name="TextBox 83">
+            <a:extLst>
+              <a:ext uri="{FF2B5EF4-FFF2-40B4-BE49-F238E27FC236}">
+                <a16:creationId xmlns:a16="http://schemas.microsoft.com/office/drawing/2014/main" id="{465A98EB-4880-884F-D153-0515CE8BDEB2}"/>
+              </a:ext>
+            </a:extLst>
+          </p:cNvPr>
+          <p:cNvSpPr txBox="1"/>
+          <p:nvPr/>
+        </p:nvSpPr>
+        <p:spPr>
+          <a:xfrm>
+            <a:off x="4265205" y="5181420"/>
+            <a:ext cx="245580" cy="230832"/>
+          </a:xfrm>
+          <a:prstGeom prst="rect">
+            <a:avLst/>
+          </a:prstGeom>
+          <a:noFill/>
+        </p:spPr>
+        <p:txBody>
+          <a:bodyPr wrap="none" rtlCol="0">
+            <a:spAutoFit/>
+          </a:bodyPr>
+          <a:lstStyle/>
+          <a:p>
+            <a:pPr algn="ctr"/>
+            <a:r>
+              <a:rPr lang="en-US" sz="900" dirty="0"/>
+              <a:t>0</a:t>
+            </a:r>
+          </a:p>
+        </p:txBody>
+      </p:sp>
+      <p:sp>
+        <p:nvSpPr>
+          <p:cNvPr id="86" name="TextBox 85">
+            <a:extLst>
+              <a:ext uri="{FF2B5EF4-FFF2-40B4-BE49-F238E27FC236}">
+                <a16:creationId xmlns:a16="http://schemas.microsoft.com/office/drawing/2014/main" id="{33E037D7-FFD6-1A3F-9638-8C8F09EEE8FF}"/>
+              </a:ext>
+            </a:extLst>
+          </p:cNvPr>
+          <p:cNvSpPr txBox="1"/>
+          <p:nvPr/>
+        </p:nvSpPr>
+        <p:spPr>
+          <a:xfrm>
+            <a:off x="4624446" y="5604159"/>
+            <a:ext cx="574196" cy="246221"/>
+          </a:xfrm>
+          <a:prstGeom prst="rect">
+            <a:avLst/>
+          </a:prstGeom>
+          <a:noFill/>
+        </p:spPr>
+        <p:txBody>
+          <a:bodyPr wrap="square" rtlCol="0">
+            <a:spAutoFit/>
+          </a:bodyPr>
+          <a:lstStyle/>
+          <a:p>
+            <a:pPr algn="ctr"/>
+            <a:r>
+              <a:rPr lang="en-US" sz="1000" dirty="0"/>
+              <a:t>Stall</a:t>
+            </a:r>
+          </a:p>
+        </p:txBody>
+      </p:sp>
+      <p:sp>
+        <p:nvSpPr>
+          <p:cNvPr id="88" name="TextBox 87">
+            <a:extLst>
+              <a:ext uri="{FF2B5EF4-FFF2-40B4-BE49-F238E27FC236}">
+                <a16:creationId xmlns:a16="http://schemas.microsoft.com/office/drawing/2014/main" id="{3444F36D-44DB-30F1-9A93-0662301A031E}"/>
+              </a:ext>
+            </a:extLst>
+          </p:cNvPr>
+          <p:cNvSpPr txBox="1"/>
+          <p:nvPr/>
+        </p:nvSpPr>
+        <p:spPr>
+          <a:xfrm>
+            <a:off x="3230284" y="5189712"/>
+            <a:ext cx="861489" cy="246221"/>
+          </a:xfrm>
+          <a:prstGeom prst="rect">
+            <a:avLst/>
+          </a:prstGeom>
+          <a:noFill/>
+        </p:spPr>
+        <p:txBody>
+          <a:bodyPr wrap="square" rtlCol="0">
+            <a:spAutoFit/>
+          </a:bodyPr>
+          <a:lstStyle/>
+          <a:p>
+            <a:pPr algn="ctr"/>
+            <a:r>
+              <a:rPr lang="en-US" sz="1000" dirty="0" err="1"/>
+              <a:t>stall_count</a:t>
+            </a:r>
+            <a:endParaRPr lang="en-US" sz="1000" dirty="0"/>
+          </a:p>
+        </p:txBody>
+      </p:sp>
+      <p:sp>
+        <p:nvSpPr>
+          <p:cNvPr id="92" name="TextBox 91">
+            <a:extLst>
+              <a:ext uri="{FF2B5EF4-FFF2-40B4-BE49-F238E27FC236}">
+                <a16:creationId xmlns:a16="http://schemas.microsoft.com/office/drawing/2014/main" id="{17776570-4E75-3096-0631-C034786BC80E}"/>
+              </a:ext>
+            </a:extLst>
+          </p:cNvPr>
+          <p:cNvSpPr txBox="1"/>
+          <p:nvPr/>
+        </p:nvSpPr>
+        <p:spPr>
+          <a:xfrm>
+            <a:off x="3512283" y="4407829"/>
+            <a:ext cx="861489" cy="246221"/>
+          </a:xfrm>
+          <a:prstGeom prst="rect">
+            <a:avLst/>
+          </a:prstGeom>
+          <a:noFill/>
+        </p:spPr>
+        <p:txBody>
+          <a:bodyPr wrap="square" rtlCol="0">
+            <a:spAutoFit/>
+          </a:bodyPr>
+          <a:lstStyle/>
+          <a:p>
+            <a:pPr algn="ctr"/>
+            <a:r>
+              <a:rPr lang="en-US" sz="1000" dirty="0" err="1"/>
+              <a:t>start_stall</a:t>
+            </a:r>
+            <a:endParaRPr lang="en-US" sz="1000" dirty="0"/>
+          </a:p>
+        </p:txBody>
+      </p:sp>
     </p:spTree>
     <p:extLst>
       <p:ext uri="{BB962C8B-B14F-4D97-AF65-F5344CB8AC3E}">

</xml_diff>